<commit_message>
deck: say that the robots talk to each other over radio
</commit_message>
<xml_diff>
--- a/ppt/Saathi_Round2.pptx
+++ b/ppt/Saathi_Round2.pptx
@@ -17373,7 +17373,7 @@
                 </a:solidFill>
                 <a:latin typeface="Montserrat"/>
               </a:rPr>
-              <a:t>SHARED MEMORY</a:t>
+              <a:t>RADIO · SHARED MEMORY</a:t>
             </a:r>
           </a:p>
           <a:p>
@@ -17392,7 +17392,7 @@
                 </a:solidFill>
                 <a:latin typeface="Montserrat"/>
               </a:rPr>
-              <a:t>Who each robot saw: where, when, clothes, height. Never a face.</a:t>
+              <a:t>Robots talk to each other: who they saw, where they are, who searches where. Never a face.</a:t>
             </a:r>
           </a:p>
         </p:txBody>
@@ -22254,7 +22254,7 @@
                 </a:solidFill>
                 <a:latin typeface="Montserrat"/>
               </a:rPr>
-              <a:t>2 robots share memory</a:t>
+              <a:t>2 robots talk + share memory</a:t>
             </a:r>
           </a:p>
         </p:txBody>
@@ -23719,7 +23719,7 @@
                 </a:solidFill>
                 <a:latin typeface="Montserrat"/>
               </a:rPr>
-              <a:t>Two Saathis, one run: papa reports “laal t-shirt” at the help desk; Saathi-1 stays with him, Saathi-2 goes where the memory says the boy is now (orange glow).</a:t>
+              <a:t>Two Saathis, one run: papa reports “laal t-shirt” at the help desk. The robots talk over radio (group chat, right): Saathi-1 stays with him, Saathi-2 goes where the memory says the boy is now (orange glow).</a:t>
             </a:r>
           </a:p>
         </p:txBody>
@@ -24143,7 +24143,7 @@
                 </a:solidFill>
                 <a:latin typeface="Montserrat"/>
               </a:rPr>
-              <a:t>robots split the places; one stays with papa</a:t>
+              <a:t>robots talk over radio, split the places; one stays with papa</a:t>
             </a:r>
           </a:p>
         </p:txBody>

</xml_diff>